<commit_message>
Improve slide annotation and rule contrast
Co-authored-by: MasatoshiSano <MasatoshiSano@users.noreply.github.com>
</commit_message>
<xml_diff>
--- a/docs/textbook/slides/SMEC_visual_diagram_template.pptx
+++ b/docs/textbook/slides/SMEC_visual_diagram_template.pptx
@@ -3270,7 +3270,7 @@
             <a:r>
               <a:rPr sz="1800" b="0">
                 <a:solidFill>
-                  <a:srgbClr val="52606D"/>
+                  <a:srgbClr val="475467"/>
                 </a:solidFill>
                 <a:latin typeface="Noto Sans"/>
                 <a:ea typeface="Noto Sans"/>
@@ -3297,7 +3297,7 @@
           </a:prstGeom>
           <a:ln w="10160">
             <a:solidFill>
-              <a:srgbClr val="D5DBE1"/>
+              <a:srgbClr val="C9D0D7"/>
             </a:solidFill>
           </a:ln>
         </p:spPr>
@@ -3386,7 +3386,7 @@
             <a:r>
               <a:rPr sz="1000" b="0">
                 <a:solidFill>
-                  <a:srgbClr val="52606D"/>
+                  <a:srgbClr val="475467"/>
                 </a:solidFill>
                 <a:latin typeface="Noto Sans"/>
                 <a:ea typeface="Noto Sans"/>
@@ -3466,7 +3466,7 @@
             <a:r>
               <a:rPr sz="1000" b="0">
                 <a:solidFill>
-                  <a:srgbClr val="52606D"/>
+                  <a:srgbClr val="475467"/>
                 </a:solidFill>
                 <a:latin typeface="Noto Sans"/>
                 <a:ea typeface="Noto Sans"/>
@@ -3506,7 +3506,7 @@
             <a:r>
               <a:rPr sz="1100" b="1">
                 <a:solidFill>
-                  <a:srgbClr val="52606D"/>
+                  <a:srgbClr val="475467"/>
                 </a:solidFill>
                 <a:latin typeface="Noto Sans"/>
                 <a:ea typeface="Noto Sans"/>
@@ -3626,7 +3626,7 @@
             <a:r>
               <a:rPr sz="1500" b="0">
                 <a:solidFill>
-                  <a:srgbClr val="52606D"/>
+                  <a:srgbClr val="475467"/>
                 </a:solidFill>
                 <a:latin typeface="Noto Sans"/>
                 <a:ea typeface="Noto Sans"/>
@@ -3668,7 +3668,7 @@
             <a:r>
               <a:rPr sz="850" b="0">
                 <a:solidFill>
-                  <a:srgbClr val="52606D"/>
+                  <a:srgbClr val="475467"/>
                 </a:solidFill>
                 <a:latin typeface="Noto Sans"/>
                 <a:ea typeface="Noto Sans"/>
@@ -3800,7 +3800,7 @@
           </a:prstGeom>
           <a:ln w="10160">
             <a:solidFill>
-              <a:srgbClr val="D5DBE1"/>
+              <a:srgbClr val="C9D0D7"/>
             </a:solidFill>
           </a:ln>
         </p:spPr>
@@ -3835,7 +3835,7 @@
           </a:prstGeom>
           <a:ln w="7620">
             <a:solidFill>
-              <a:srgbClr val="D5DBE1"/>
+              <a:srgbClr val="C9D0D7"/>
             </a:solidFill>
           </a:ln>
         </p:spPr>
@@ -3884,7 +3884,7 @@
             <a:r>
               <a:rPr sz="850" b="0">
                 <a:solidFill>
-                  <a:srgbClr val="52606D"/>
+                  <a:srgbClr val="475467"/>
                 </a:solidFill>
                 <a:latin typeface="Noto Sans"/>
                 <a:ea typeface="Noto Sans"/>
@@ -3950,7 +3950,7 @@
           </a:prstGeom>
           <a:ln w="15240">
             <a:solidFill>
-              <a:srgbClr val="52606D"/>
+              <a:srgbClr val="475467"/>
             </a:solidFill>
           </a:ln>
         </p:spPr>
@@ -4122,7 +4122,7 @@
             <a:r>
               <a:rPr sz="1050" b="0">
                 <a:solidFill>
-                  <a:srgbClr val="52606D"/>
+                  <a:srgbClr val="475467"/>
                 </a:solidFill>
                 <a:latin typeface="Noto Sans"/>
                 <a:ea typeface="Noto Sans"/>
@@ -4285,7 +4285,7 @@
             <a:r>
               <a:rPr sz="1050" b="0">
                 <a:solidFill>
-                  <a:srgbClr val="52606D"/>
+                  <a:srgbClr val="475467"/>
                 </a:solidFill>
                 <a:latin typeface="Noto Sans"/>
                 <a:ea typeface="Noto Sans"/>
@@ -4448,7 +4448,7 @@
             <a:r>
               <a:rPr sz="1050" b="0">
                 <a:solidFill>
-                  <a:srgbClr val="52606D"/>
+                  <a:srgbClr val="475467"/>
                 </a:solidFill>
                 <a:latin typeface="Noto Sans"/>
                 <a:ea typeface="Noto Sans"/>
@@ -4611,7 +4611,7 @@
             <a:r>
               <a:rPr sz="1050" b="0">
                 <a:solidFill>
-                  <a:srgbClr val="52606D"/>
+                  <a:srgbClr val="475467"/>
                 </a:solidFill>
                 <a:latin typeface="Noto Sans"/>
                 <a:ea typeface="Noto Sans"/>
@@ -4743,7 +4743,7 @@
           </a:prstGeom>
           <a:ln w="10160">
             <a:solidFill>
-              <a:srgbClr val="D5DBE1"/>
+              <a:srgbClr val="C9D0D7"/>
             </a:solidFill>
           </a:ln>
         </p:spPr>
@@ -4778,7 +4778,7 @@
           </a:prstGeom>
           <a:ln w="7620">
             <a:solidFill>
-              <a:srgbClr val="D5DBE1"/>
+              <a:srgbClr val="C9D0D7"/>
             </a:solidFill>
           </a:ln>
         </p:spPr>
@@ -4827,7 +4827,7 @@
             <a:r>
               <a:rPr sz="850" b="0">
                 <a:solidFill>
-                  <a:srgbClr val="52606D"/>
+                  <a:srgbClr val="475467"/>
                 </a:solidFill>
                 <a:latin typeface="Noto Sans"/>
                 <a:ea typeface="Noto Sans"/>
@@ -4896,7 +4896,7 @@
           </a:solidFill>
           <a:ln w="7620">
             <a:solidFill>
-              <a:srgbClr val="D5DBE1"/>
+              <a:srgbClr val="C9D0D7"/>
             </a:solidFill>
           </a:ln>
         </p:spPr>
@@ -4981,7 +4981,7 @@
           </a:prstGeom>
           <a:ln w="10160">
             <a:solidFill>
-              <a:srgbClr val="D5DBE1"/>
+              <a:srgbClr val="C9D0D7"/>
             </a:solidFill>
           </a:ln>
         </p:spPr>
@@ -5016,7 +5016,7 @@
           </a:prstGeom>
           <a:ln w="10160">
             <a:solidFill>
-              <a:srgbClr val="D5DBE1"/>
+              <a:srgbClr val="C9D0D7"/>
             </a:solidFill>
           </a:ln>
         </p:spPr>
@@ -5105,7 +5105,7 @@
             <a:r>
               <a:rPr sz="1050" b="0">
                 <a:solidFill>
-                  <a:srgbClr val="52606D"/>
+                  <a:srgbClr val="475467"/>
                 </a:solidFill>
                 <a:latin typeface="Noto Sans"/>
                 <a:ea typeface="Noto Sans"/>
@@ -5185,7 +5185,7 @@
             <a:r>
               <a:rPr sz="1050" b="0">
                 <a:solidFill>
-                  <a:srgbClr val="52606D"/>
+                  <a:srgbClr val="475467"/>
                 </a:solidFill>
                 <a:latin typeface="Noto Sans"/>
                 <a:ea typeface="Noto Sans"/>
@@ -5265,7 +5265,7 @@
             <a:r>
               <a:rPr sz="1050" b="0">
                 <a:solidFill>
-                  <a:srgbClr val="52606D"/>
+                  <a:srgbClr val="475467"/>
                 </a:solidFill>
                 <a:latin typeface="Noto Sans"/>
                 <a:ea typeface="Noto Sans"/>
@@ -5345,7 +5345,7 @@
             <a:r>
               <a:rPr sz="1050" b="0">
                 <a:solidFill>
-                  <a:srgbClr val="52606D"/>
+                  <a:srgbClr val="475467"/>
                 </a:solidFill>
                 <a:latin typeface="Noto Sans"/>
                 <a:ea typeface="Noto Sans"/>
@@ -5385,7 +5385,7 @@
             <a:r>
               <a:rPr sz="1000" b="1">
                 <a:solidFill>
-                  <a:srgbClr val="52606D"/>
+                  <a:srgbClr val="475467"/>
                 </a:solidFill>
                 <a:latin typeface="Noto Sans"/>
                 <a:ea typeface="Noto Sans"/>
@@ -5425,7 +5425,7 @@
             <a:r>
               <a:rPr sz="1000" b="1">
                 <a:solidFill>
-                  <a:srgbClr val="52606D"/>
+                  <a:srgbClr val="475467"/>
                 </a:solidFill>
                 <a:latin typeface="Noto Sans"/>
                 <a:ea typeface="Noto Sans"/>
@@ -5557,7 +5557,7 @@
           </a:prstGeom>
           <a:ln w="10160">
             <a:solidFill>
-              <a:srgbClr val="D5DBE1"/>
+              <a:srgbClr val="C9D0D7"/>
             </a:solidFill>
           </a:ln>
         </p:spPr>
@@ -5592,7 +5592,7 @@
           </a:prstGeom>
           <a:ln w="7620">
             <a:solidFill>
-              <a:srgbClr val="D5DBE1"/>
+              <a:srgbClr val="C9D0D7"/>
             </a:solidFill>
           </a:ln>
         </p:spPr>
@@ -5641,7 +5641,7 @@
             <a:r>
               <a:rPr sz="850" b="0">
                 <a:solidFill>
-                  <a:srgbClr val="52606D"/>
+                  <a:srgbClr val="475467"/>
                 </a:solidFill>
                 <a:latin typeface="Noto Sans"/>
                 <a:ea typeface="Noto Sans"/>
@@ -5710,7 +5710,7 @@
           </a:solidFill>
           <a:ln w="7620">
             <a:solidFill>
-              <a:srgbClr val="D5DBE1"/>
+              <a:srgbClr val="C9D0D7"/>
             </a:solidFill>
           </a:ln>
         </p:spPr>
@@ -5849,7 +5849,7 @@
             <a:r>
               <a:rPr sz="1050" b="0">
                 <a:solidFill>
-                  <a:srgbClr val="52606D"/>
+                  <a:srgbClr val="475467"/>
                 </a:solidFill>
                 <a:latin typeface="Noto Sans"/>
                 <a:ea typeface="Noto Sans"/>
@@ -5875,7 +5875,7 @@
           </a:prstGeom>
           <a:ln w="12700">
             <a:solidFill>
-              <a:srgbClr val="D5DBE1"/>
+              <a:srgbClr val="C9D0D7"/>
             </a:solidFill>
           </a:ln>
         </p:spPr>
@@ -5910,7 +5910,7 @@
           </a:prstGeom>
           <a:ln w="12700">
             <a:solidFill>
-              <a:srgbClr val="D5DBE1"/>
+              <a:srgbClr val="C9D0D7"/>
             </a:solidFill>
           </a:ln>
         </p:spPr>
@@ -5945,7 +5945,7 @@
           </a:prstGeom>
           <a:ln w="12700">
             <a:solidFill>
-              <a:srgbClr val="D5DBE1"/>
+              <a:srgbClr val="C9D0D7"/>
             </a:solidFill>
           </a:ln>
         </p:spPr>
@@ -5983,7 +5983,7 @@
           </a:solidFill>
           <a:ln w="7620">
             <a:solidFill>
-              <a:srgbClr val="D5DBE1"/>
+              <a:srgbClr val="C9D0D7"/>
             </a:solidFill>
           </a:ln>
         </p:spPr>
@@ -6122,7 +6122,7 @@
             <a:r>
               <a:rPr sz="1050" b="0">
                 <a:solidFill>
-                  <a:srgbClr val="52606D"/>
+                  <a:srgbClr val="475467"/>
                 </a:solidFill>
                 <a:latin typeface="Noto Sans"/>
                 <a:ea typeface="Noto Sans"/>
@@ -6148,7 +6148,7 @@
           </a:prstGeom>
           <a:ln w="12700">
             <a:solidFill>
-              <a:srgbClr val="D5DBE1"/>
+              <a:srgbClr val="C9D0D7"/>
             </a:solidFill>
           </a:ln>
         </p:spPr>
@@ -6197,7 +6197,7 @@
             <a:r>
               <a:rPr sz="1150" b="0">
                 <a:solidFill>
-                  <a:srgbClr val="52606D"/>
+                  <a:srgbClr val="475467"/>
                 </a:solidFill>
                 <a:latin typeface="Noto Sans"/>
                 <a:ea typeface="Noto Sans"/>
@@ -6223,7 +6223,7 @@
           </a:prstGeom>
           <a:ln w="12700">
             <a:solidFill>
-              <a:srgbClr val="D5DBE1"/>
+              <a:srgbClr val="C9D0D7"/>
             </a:solidFill>
           </a:ln>
         </p:spPr>
@@ -6261,7 +6261,7 @@
           </a:solidFill>
           <a:ln w="7620">
             <a:solidFill>
-              <a:srgbClr val="D5DBE1"/>
+              <a:srgbClr val="C9D0D7"/>
             </a:solidFill>
           </a:ln>
         </p:spPr>
@@ -6400,7 +6400,7 @@
             <a:r>
               <a:rPr sz="1050" b="0">
                 <a:solidFill>
-                  <a:srgbClr val="52606D"/>
+                  <a:srgbClr val="475467"/>
                 </a:solidFill>
                 <a:latin typeface="Noto Sans"/>
                 <a:ea typeface="Noto Sans"/>
@@ -6426,7 +6426,7 @@
           </a:prstGeom>
           <a:ln w="12700">
             <a:solidFill>
-              <a:srgbClr val="D5DBE1"/>
+              <a:srgbClr val="C9D0D7"/>
             </a:solidFill>
           </a:ln>
         </p:spPr>
@@ -6475,7 +6475,7 @@
             <a:r>
               <a:rPr sz="1150" b="0">
                 <a:solidFill>
-                  <a:srgbClr val="52606D"/>
+                  <a:srgbClr val="475467"/>
                 </a:solidFill>
                 <a:latin typeface="Noto Sans"/>
                 <a:ea typeface="Noto Sans"/>
@@ -6501,7 +6501,7 @@
           </a:prstGeom>
           <a:ln w="12700">
             <a:solidFill>
-              <a:srgbClr val="D5DBE1"/>
+              <a:srgbClr val="C9D0D7"/>
             </a:solidFill>
           </a:ln>
         </p:spPr>
@@ -6539,7 +6539,7 @@
           </a:solidFill>
           <a:ln w="7620">
             <a:solidFill>
-              <a:srgbClr val="D5DBE1"/>
+              <a:srgbClr val="C9D0D7"/>
             </a:solidFill>
           </a:ln>
         </p:spPr>
@@ -6678,7 +6678,7 @@
             <a:r>
               <a:rPr sz="1050" b="0">
                 <a:solidFill>
-                  <a:srgbClr val="52606D"/>
+                  <a:srgbClr val="475467"/>
                 </a:solidFill>
                 <a:latin typeface="Noto Sans"/>
                 <a:ea typeface="Noto Sans"/>
@@ -6704,7 +6704,7 @@
           </a:prstGeom>
           <a:ln w="12700">
             <a:solidFill>
-              <a:srgbClr val="D5DBE1"/>
+              <a:srgbClr val="C9D0D7"/>
             </a:solidFill>
           </a:ln>
         </p:spPr>
@@ -6753,7 +6753,7 @@
             <a:r>
               <a:rPr sz="1150" b="0">
                 <a:solidFill>
-                  <a:srgbClr val="52606D"/>
+                  <a:srgbClr val="475467"/>
                 </a:solidFill>
                 <a:latin typeface="Noto Sans"/>
                 <a:ea typeface="Noto Sans"/>
@@ -6885,7 +6885,7 @@
           </a:prstGeom>
           <a:ln w="10160">
             <a:solidFill>
-              <a:srgbClr val="D5DBE1"/>
+              <a:srgbClr val="C9D0D7"/>
             </a:solidFill>
           </a:ln>
         </p:spPr>
@@ -6920,7 +6920,7 @@
           </a:prstGeom>
           <a:ln w="7620">
             <a:solidFill>
-              <a:srgbClr val="D5DBE1"/>
+              <a:srgbClr val="C9D0D7"/>
             </a:solidFill>
           </a:ln>
         </p:spPr>
@@ -6969,7 +6969,7 @@
             <a:r>
               <a:rPr sz="850" b="0">
                 <a:solidFill>
-                  <a:srgbClr val="52606D"/>
+                  <a:srgbClr val="475467"/>
                 </a:solidFill>
                 <a:latin typeface="Noto Sans"/>
                 <a:ea typeface="Noto Sans"/>
@@ -7121,7 +7121,7 @@
           </a:solidFill>
           <a:ln w="7620">
             <a:solidFill>
-              <a:srgbClr val="D5DBE1"/>
+              <a:srgbClr val="C9D0D7"/>
             </a:solidFill>
           </a:ln>
         </p:spPr>
@@ -7260,7 +7260,7 @@
             <a:r>
               <a:rPr sz="1050" b="0">
                 <a:solidFill>
-                  <a:srgbClr val="52606D"/>
+                  <a:srgbClr val="475467"/>
                 </a:solidFill>
                 <a:latin typeface="Noto Sans"/>
                 <a:ea typeface="Noto Sans"/>
@@ -7286,7 +7286,7 @@
           </a:prstGeom>
           <a:ln w="12700">
             <a:solidFill>
-              <a:srgbClr val="D5DBE1"/>
+              <a:srgbClr val="C9D0D7"/>
             </a:solidFill>
           </a:ln>
         </p:spPr>
@@ -7324,7 +7324,7 @@
           </a:solidFill>
           <a:ln w="7620">
             <a:solidFill>
-              <a:srgbClr val="D5DBE1"/>
+              <a:srgbClr val="C9D0D7"/>
             </a:solidFill>
           </a:ln>
         </p:spPr>
@@ -7463,7 +7463,7 @@
             <a:r>
               <a:rPr sz="1050" b="0">
                 <a:solidFill>
-                  <a:srgbClr val="52606D"/>
+                  <a:srgbClr val="475467"/>
                 </a:solidFill>
                 <a:latin typeface="Noto Sans"/>
                 <a:ea typeface="Noto Sans"/>
@@ -7489,7 +7489,7 @@
           </a:prstGeom>
           <a:ln w="12700">
             <a:solidFill>
-              <a:srgbClr val="D5DBE1"/>
+              <a:srgbClr val="C9D0D7"/>
             </a:solidFill>
           </a:ln>
         </p:spPr>
@@ -7527,7 +7527,7 @@
           </a:solidFill>
           <a:ln w="7620">
             <a:solidFill>
-              <a:srgbClr val="D5DBE1"/>
+              <a:srgbClr val="C9D0D7"/>
             </a:solidFill>
           </a:ln>
         </p:spPr>
@@ -7666,7 +7666,7 @@
             <a:r>
               <a:rPr sz="1050" b="0">
                 <a:solidFill>
-                  <a:srgbClr val="52606D"/>
+                  <a:srgbClr val="475467"/>
                 </a:solidFill>
                 <a:latin typeface="Noto Sans"/>
                 <a:ea typeface="Noto Sans"/>
@@ -7692,7 +7692,7 @@
           </a:prstGeom>
           <a:ln w="12700">
             <a:solidFill>
-              <a:srgbClr val="D5DBE1"/>
+              <a:srgbClr val="C9D0D7"/>
             </a:solidFill>
           </a:ln>
         </p:spPr>
@@ -7730,7 +7730,7 @@
           </a:solidFill>
           <a:ln w="7620">
             <a:solidFill>
-              <a:srgbClr val="D5DBE1"/>
+              <a:srgbClr val="C9D0D7"/>
             </a:solidFill>
           </a:ln>
         </p:spPr>
@@ -7869,7 +7869,7 @@
             <a:r>
               <a:rPr sz="1050" b="0">
                 <a:solidFill>
-                  <a:srgbClr val="52606D"/>
+                  <a:srgbClr val="475467"/>
                 </a:solidFill>
                 <a:latin typeface="Noto Sans"/>
                 <a:ea typeface="Noto Sans"/>
@@ -7895,7 +7895,7 @@
           </a:prstGeom>
           <a:ln w="12700">
             <a:solidFill>
-              <a:srgbClr val="D5DBE1"/>
+              <a:srgbClr val="C9D0D7"/>
             </a:solidFill>
           </a:ln>
         </p:spPr>
@@ -7944,7 +7944,7 @@
             <a:r>
               <a:rPr sz="1000" b="0">
                 <a:solidFill>
-                  <a:srgbClr val="52606D"/>
+                  <a:srgbClr val="475467"/>
                 </a:solidFill>
                 <a:latin typeface="Noto Sans"/>
                 <a:ea typeface="Noto Sans"/>
@@ -8076,7 +8076,7 @@
           </a:prstGeom>
           <a:ln w="10160">
             <a:solidFill>
-              <a:srgbClr val="D5DBE1"/>
+              <a:srgbClr val="C9D0D7"/>
             </a:solidFill>
           </a:ln>
         </p:spPr>
@@ -8111,7 +8111,7 @@
           </a:prstGeom>
           <a:ln w="7620">
             <a:solidFill>
-              <a:srgbClr val="D5DBE1"/>
+              <a:srgbClr val="C9D0D7"/>
             </a:solidFill>
           </a:ln>
         </p:spPr>
@@ -8160,7 +8160,7 @@
             <a:r>
               <a:rPr sz="850" b="0">
                 <a:solidFill>
-                  <a:srgbClr val="52606D"/>
+                  <a:srgbClr val="475467"/>
                 </a:solidFill>
                 <a:latin typeface="Noto Sans"/>
                 <a:ea typeface="Noto Sans"/>
@@ -8240,7 +8240,7 @@
             <a:r>
               <a:rPr sz="900" b="1">
                 <a:solidFill>
-                  <a:srgbClr val="52606D"/>
+                  <a:srgbClr val="475467"/>
                 </a:solidFill>
                 <a:latin typeface="Noto Sans"/>
                 <a:ea typeface="Noto Sans"/>
@@ -8346,7 +8346,7 @@
           </a:prstGeom>
           <a:ln w="10160">
             <a:solidFill>
-              <a:srgbClr val="D5DBE1"/>
+              <a:srgbClr val="C9D0D7"/>
             </a:solidFill>
           </a:ln>
         </p:spPr>
@@ -8462,7 +8462,7 @@
           </a:prstGeom>
           <a:ln w="10160">
             <a:solidFill>
-              <a:srgbClr val="D5DBE1"/>
+              <a:srgbClr val="C9D0D7"/>
             </a:solidFill>
           </a:ln>
         </p:spPr>
@@ -8591,7 +8591,7 @@
             <a:r>
               <a:rPr sz="1200" b="0">
                 <a:solidFill>
-                  <a:srgbClr val="52606D"/>
+                  <a:srgbClr val="475467"/>
                 </a:solidFill>
                 <a:latin typeface="Noto Sans"/>
                 <a:ea typeface="Noto Sans"/>
@@ -8724,7 +8724,7 @@
           </a:prstGeom>
           <a:ln w="10160">
             <a:solidFill>
-              <a:srgbClr val="D5DBE1"/>
+              <a:srgbClr val="C9D0D7"/>
             </a:solidFill>
           </a:ln>
         </p:spPr>
@@ -8759,7 +8759,7 @@
           </a:prstGeom>
           <a:ln w="7620">
             <a:solidFill>
-              <a:srgbClr val="D5DBE1"/>
+              <a:srgbClr val="C9D0D7"/>
             </a:solidFill>
           </a:ln>
         </p:spPr>
@@ -8808,7 +8808,7 @@
             <a:r>
               <a:rPr sz="850" b="0">
                 <a:solidFill>
-                  <a:srgbClr val="52606D"/>
+                  <a:srgbClr val="475467"/>
                 </a:solidFill>
                 <a:latin typeface="Noto Sans"/>
                 <a:ea typeface="Noto Sans"/>
@@ -8888,7 +8888,7 @@
             <a:r>
               <a:rPr sz="1000" b="1">
                 <a:solidFill>
-                  <a:srgbClr val="52606D"/>
+                  <a:srgbClr val="475467"/>
                 </a:solidFill>
                 <a:latin typeface="Noto Sans"/>
                 <a:ea typeface="Noto Sans"/>
@@ -8968,7 +8968,7 @@
             <a:r>
               <a:rPr sz="850" b="0">
                 <a:solidFill>
-                  <a:srgbClr val="52606D"/>
+                  <a:srgbClr val="475467"/>
                 </a:solidFill>
                 <a:latin typeface="Noto Sans"/>
                 <a:ea typeface="Noto Sans"/>
@@ -9008,7 +9008,7 @@
             <a:r>
               <a:rPr sz="1000" b="1">
                 <a:solidFill>
-                  <a:srgbClr val="52606D"/>
+                  <a:srgbClr val="475467"/>
                 </a:solidFill>
                 <a:latin typeface="Noto Sans"/>
                 <a:ea typeface="Noto Sans"/>
@@ -9088,7 +9088,7 @@
             <a:r>
               <a:rPr sz="850" b="0">
                 <a:solidFill>
-                  <a:srgbClr val="52606D"/>
+                  <a:srgbClr val="475467"/>
                 </a:solidFill>
                 <a:latin typeface="Noto Sans"/>
                 <a:ea typeface="Noto Sans"/>
@@ -9128,7 +9128,7 @@
             <a:r>
               <a:rPr sz="1000" b="1">
                 <a:solidFill>
-                  <a:srgbClr val="52606D"/>
+                  <a:srgbClr val="475467"/>
                 </a:solidFill>
                 <a:latin typeface="Noto Sans"/>
                 <a:ea typeface="Noto Sans"/>
@@ -9208,7 +9208,7 @@
             <a:r>
               <a:rPr sz="850" b="0">
                 <a:solidFill>
-                  <a:srgbClr val="52606D"/>
+                  <a:srgbClr val="475467"/>
                 </a:solidFill>
                 <a:latin typeface="Noto Sans"/>
                 <a:ea typeface="Noto Sans"/>
@@ -9234,7 +9234,7 @@
           </a:prstGeom>
           <a:ln w="10160">
             <a:solidFill>
-              <a:srgbClr val="D5DBE1"/>
+              <a:srgbClr val="C9D0D7"/>
             </a:solidFill>
           </a:ln>
         </p:spPr>
@@ -9326,7 +9326,7 @@
             <a:r>
               <a:rPr sz="800" b="0">
                 <a:solidFill>
-                  <a:srgbClr val="52606D"/>
+                  <a:srgbClr val="475467"/>
                 </a:solidFill>
                 <a:latin typeface="Noto Sans"/>
                 <a:ea typeface="Noto Sans"/>
@@ -9409,7 +9409,7 @@
             <a:r>
               <a:rPr sz="800" b="0">
                 <a:solidFill>
-                  <a:srgbClr val="52606D"/>
+                  <a:srgbClr val="475467"/>
                 </a:solidFill>
                 <a:latin typeface="Noto Sans"/>
                 <a:ea typeface="Noto Sans"/>
@@ -9492,7 +9492,7 @@
             <a:r>
               <a:rPr sz="800" b="0">
                 <a:solidFill>
-                  <a:srgbClr val="52606D"/>
+                  <a:srgbClr val="475467"/>
                 </a:solidFill>
                 <a:latin typeface="Noto Sans"/>
                 <a:ea typeface="Noto Sans"/>
@@ -9575,7 +9575,7 @@
             <a:r>
               <a:rPr sz="800" b="0">
                 <a:solidFill>
-                  <a:srgbClr val="52606D"/>
+                  <a:srgbClr val="475467"/>
                 </a:solidFill>
                 <a:latin typeface="Noto Sans"/>
                 <a:ea typeface="Noto Sans"/>
@@ -9644,7 +9644,7 @@
           </a:solidFill>
           <a:ln w="5080">
             <a:solidFill>
-              <a:srgbClr val="D5DBE1"/>
+              <a:srgbClr val="C9D0D7"/>
             </a:solidFill>
           </a:ln>
         </p:spPr>
@@ -9689,7 +9689,7 @@
           </a:solidFill>
           <a:ln w="5080">
             <a:solidFill>
-              <a:srgbClr val="D5DBE1"/>
+              <a:srgbClr val="C9D0D7"/>
             </a:solidFill>
           </a:ln>
         </p:spPr>
@@ -9814,7 +9814,7 @@
           </a:solidFill>
           <a:ln w="5080">
             <a:solidFill>
-              <a:srgbClr val="D5DBE1"/>
+              <a:srgbClr val="C9D0D7"/>
             </a:solidFill>
           </a:ln>
         </p:spPr>
@@ -9859,7 +9859,7 @@
           </a:solidFill>
           <a:ln w="5080">
             <a:solidFill>
-              <a:srgbClr val="D5DBE1"/>
+              <a:srgbClr val="C9D0D7"/>
             </a:solidFill>
           </a:ln>
         </p:spPr>
@@ -9955,7 +9955,7 @@
             <a:r>
               <a:rPr sz="950" b="0">
                 <a:solidFill>
-                  <a:srgbClr val="52606D"/>
+                  <a:srgbClr val="475467"/>
                 </a:solidFill>
                 <a:latin typeface="Noto Sans"/>
                 <a:ea typeface="Noto Sans"/>
@@ -9984,7 +9984,7 @@
           </a:solidFill>
           <a:ln w="5080">
             <a:solidFill>
-              <a:srgbClr val="D5DBE1"/>
+              <a:srgbClr val="C9D0D7"/>
             </a:solidFill>
           </a:ln>
         </p:spPr>
@@ -10029,7 +10029,7 @@
           </a:solidFill>
           <a:ln w="5080">
             <a:solidFill>
-              <a:srgbClr val="D5DBE1"/>
+              <a:srgbClr val="C9D0D7"/>
             </a:solidFill>
           </a:ln>
         </p:spPr>
@@ -10125,7 +10125,7 @@
             <a:r>
               <a:rPr sz="950" b="0">
                 <a:solidFill>
-                  <a:srgbClr val="52606D"/>
+                  <a:srgbClr val="475467"/>
                 </a:solidFill>
                 <a:latin typeface="Noto Sans"/>
                 <a:ea typeface="Noto Sans"/>
@@ -10154,7 +10154,7 @@
           </a:solidFill>
           <a:ln w="5080">
             <a:solidFill>
-              <a:srgbClr val="D5DBE1"/>
+              <a:srgbClr val="C9D0D7"/>
             </a:solidFill>
           </a:ln>
         </p:spPr>
@@ -10199,7 +10199,7 @@
           </a:solidFill>
           <a:ln w="5080">
             <a:solidFill>
-              <a:srgbClr val="D5DBE1"/>
+              <a:srgbClr val="C9D0D7"/>
             </a:solidFill>
           </a:ln>
         </p:spPr>
@@ -10295,7 +10295,7 @@
             <a:r>
               <a:rPr sz="950" b="0">
                 <a:solidFill>
-                  <a:srgbClr val="52606D"/>
+                  <a:srgbClr val="475467"/>
                 </a:solidFill>
                 <a:latin typeface="Noto Sans"/>
                 <a:ea typeface="Noto Sans"/>
@@ -10427,7 +10427,7 @@
           </a:prstGeom>
           <a:ln w="10160">
             <a:solidFill>
-              <a:srgbClr val="D5DBE1"/>
+              <a:srgbClr val="C9D0D7"/>
             </a:solidFill>
           </a:ln>
         </p:spPr>
@@ -10462,7 +10462,7 @@
           </a:prstGeom>
           <a:ln w="7620">
             <a:solidFill>
-              <a:srgbClr val="D5DBE1"/>
+              <a:srgbClr val="C9D0D7"/>
             </a:solidFill>
           </a:ln>
         </p:spPr>
@@ -10511,7 +10511,7 @@
             <a:r>
               <a:rPr sz="850" b="0">
                 <a:solidFill>
-                  <a:srgbClr val="52606D"/>
+                  <a:srgbClr val="475467"/>
                 </a:solidFill>
                 <a:latin typeface="Noto Sans"/>
                 <a:ea typeface="Noto Sans"/>
@@ -10577,7 +10577,7 @@
           </a:prstGeom>
           <a:ln w="11430">
             <a:solidFill>
-              <a:srgbClr val="52606D"/>
+              <a:srgbClr val="475467"/>
             </a:solidFill>
           </a:ln>
         </p:spPr>
@@ -10612,7 +10612,7 @@
           </a:prstGeom>
           <a:ln w="11430">
             <a:solidFill>
-              <a:srgbClr val="52606D"/>
+              <a:srgbClr val="475467"/>
             </a:solidFill>
           </a:ln>
         </p:spPr>
@@ -10661,7 +10661,7 @@
             <a:r>
               <a:rPr sz="900" b="0">
                 <a:solidFill>
-                  <a:srgbClr val="52606D"/>
+                  <a:srgbClr val="475467"/>
                 </a:solidFill>
                 <a:latin typeface="Noto Sans"/>
                 <a:ea typeface="Noto Sans"/>
@@ -10701,7 +10701,7 @@
             <a:r>
               <a:rPr sz="900" b="0">
                 <a:solidFill>
-                  <a:srgbClr val="52606D"/>
+                  <a:srgbClr val="475467"/>
                 </a:solidFill>
                 <a:latin typeface="Noto Sans"/>
                 <a:ea typeface="Noto Sans"/>
@@ -10920,7 +10920,7 @@
           </a:prstGeom>
           <a:ln w="7620">
             <a:solidFill>
-              <a:srgbClr val="D5DBE1"/>
+              <a:srgbClr val="C9D0D7"/>
             </a:solidFill>
           </a:ln>
         </p:spPr>
@@ -10955,7 +10955,7 @@
           </a:prstGeom>
           <a:ln w="7620">
             <a:solidFill>
-              <a:srgbClr val="D5DBE1"/>
+              <a:srgbClr val="C9D0D7"/>
             </a:solidFill>
           </a:ln>
         </p:spPr>
@@ -11084,7 +11084,7 @@
             <a:r>
               <a:rPr sz="1250" b="0">
                 <a:solidFill>
-                  <a:srgbClr val="52606D"/>
+                  <a:srgbClr val="475467"/>
                 </a:solidFill>
                 <a:latin typeface="Noto Sans"/>
                 <a:ea typeface="Noto Sans"/>
@@ -11164,7 +11164,7 @@
             <a:r>
               <a:rPr sz="1250" b="0">
                 <a:solidFill>
-                  <a:srgbClr val="52606D"/>
+                  <a:srgbClr val="475467"/>
                 </a:solidFill>
                 <a:latin typeface="Noto Sans"/>
                 <a:ea typeface="Noto Sans"/>
@@ -11244,7 +11244,7 @@
             <a:r>
               <a:rPr sz="1250" b="0">
                 <a:solidFill>
-                  <a:srgbClr val="52606D"/>
+                  <a:srgbClr val="475467"/>
                 </a:solidFill>
                 <a:latin typeface="Noto Sans"/>
                 <a:ea typeface="Noto Sans"/>
@@ -11376,7 +11376,7 @@
           </a:prstGeom>
           <a:ln w="10160">
             <a:solidFill>
-              <a:srgbClr val="D5DBE1"/>
+              <a:srgbClr val="C9D0D7"/>
             </a:solidFill>
           </a:ln>
         </p:spPr>
@@ -11411,7 +11411,7 @@
           </a:prstGeom>
           <a:ln w="7620">
             <a:solidFill>
-              <a:srgbClr val="D5DBE1"/>
+              <a:srgbClr val="C9D0D7"/>
             </a:solidFill>
           </a:ln>
         </p:spPr>
@@ -11460,7 +11460,7 @@
             <a:r>
               <a:rPr sz="850" b="0">
                 <a:solidFill>
-                  <a:srgbClr val="52606D"/>
+                  <a:srgbClr val="475467"/>
                 </a:solidFill>
                 <a:latin typeface="Noto Sans"/>
                 <a:ea typeface="Noto Sans"/>
@@ -11526,7 +11526,7 @@
           </a:prstGeom>
           <a:ln w="11430">
             <a:solidFill>
-              <a:srgbClr val="52606D"/>
+              <a:srgbClr val="475467"/>
             </a:solidFill>
           </a:ln>
         </p:spPr>
@@ -11561,7 +11561,7 @@
           </a:prstGeom>
           <a:ln w="11430">
             <a:solidFill>
-              <a:srgbClr val="52606D"/>
+              <a:srgbClr val="475467"/>
             </a:solidFill>
           </a:ln>
         </p:spPr>
@@ -11610,7 +11610,7 @@
             <a:r>
               <a:rPr sz="900" b="0">
                 <a:solidFill>
-                  <a:srgbClr val="52606D"/>
+                  <a:srgbClr val="475467"/>
                 </a:solidFill>
                 <a:latin typeface="Noto Sans"/>
                 <a:ea typeface="Noto Sans"/>
@@ -11650,7 +11650,7 @@
             <a:r>
               <a:rPr sz="900" b="0">
                 <a:solidFill>
-                  <a:srgbClr val="52606D"/>
+                  <a:srgbClr val="475467"/>
                 </a:solidFill>
                 <a:latin typeface="Noto Sans"/>
                 <a:ea typeface="Noto Sans"/>
@@ -12033,7 +12033,7 @@
             <a:r>
               <a:rPr sz="1250" b="0">
                 <a:solidFill>
-                  <a:srgbClr val="52606D"/>
+                  <a:srgbClr val="475467"/>
                 </a:solidFill>
                 <a:latin typeface="Noto Sans"/>
                 <a:ea typeface="Noto Sans"/>
@@ -12113,7 +12113,7 @@
             <a:r>
               <a:rPr sz="1250" b="0">
                 <a:solidFill>
-                  <a:srgbClr val="52606D"/>
+                  <a:srgbClr val="475467"/>
                 </a:solidFill>
                 <a:latin typeface="Noto Sans"/>
                 <a:ea typeface="Noto Sans"/>
@@ -12193,7 +12193,7 @@
             <a:r>
               <a:rPr sz="1250" b="0">
                 <a:solidFill>
-                  <a:srgbClr val="52606D"/>
+                  <a:srgbClr val="475467"/>
                 </a:solidFill>
                 <a:latin typeface="Noto Sans"/>
                 <a:ea typeface="Noto Sans"/>
@@ -12325,7 +12325,7 @@
           </a:prstGeom>
           <a:ln w="10160">
             <a:solidFill>
-              <a:srgbClr val="D5DBE1"/>
+              <a:srgbClr val="C9D0D7"/>
             </a:solidFill>
           </a:ln>
         </p:spPr>
@@ -12360,7 +12360,7 @@
           </a:prstGeom>
           <a:ln w="7620">
             <a:solidFill>
-              <a:srgbClr val="D5DBE1"/>
+              <a:srgbClr val="C9D0D7"/>
             </a:solidFill>
           </a:ln>
         </p:spPr>
@@ -12409,7 +12409,7 @@
             <a:r>
               <a:rPr sz="850" b="0">
                 <a:solidFill>
-                  <a:srgbClr val="52606D"/>
+                  <a:srgbClr val="475467"/>
                 </a:solidFill>
                 <a:latin typeface="Noto Sans"/>
                 <a:ea typeface="Noto Sans"/>
@@ -12475,7 +12475,7 @@
           </a:prstGeom>
           <a:ln w="11430">
             <a:solidFill>
-              <a:srgbClr val="52606D"/>
+              <a:srgbClr val="475467"/>
             </a:solidFill>
           </a:ln>
         </p:spPr>
@@ -12510,7 +12510,7 @@
           </a:prstGeom>
           <a:ln w="11430">
             <a:solidFill>
-              <a:srgbClr val="52606D"/>
+              <a:srgbClr val="475467"/>
             </a:solidFill>
           </a:ln>
         </p:spPr>
@@ -12559,7 +12559,7 @@
             <a:r>
               <a:rPr sz="900" b="0">
                 <a:solidFill>
-                  <a:srgbClr val="52606D"/>
+                  <a:srgbClr val="475467"/>
                 </a:solidFill>
                 <a:latin typeface="Noto Sans"/>
                 <a:ea typeface="Noto Sans"/>
@@ -12599,7 +12599,7 @@
             <a:r>
               <a:rPr sz="900" b="0">
                 <a:solidFill>
-                  <a:srgbClr val="52606D"/>
+                  <a:srgbClr val="475467"/>
                 </a:solidFill>
                 <a:latin typeface="Noto Sans"/>
                 <a:ea typeface="Noto Sans"/>
@@ -12625,7 +12625,7 @@
           </a:prstGeom>
           <a:ln w="15240">
             <a:solidFill>
-              <a:srgbClr val="52606D"/>
+              <a:srgbClr val="475467"/>
             </a:solidFill>
           </a:ln>
         </p:spPr>
@@ -12824,7 +12824,7 @@
             <a:r>
               <a:rPr sz="900" b="0">
                 <a:solidFill>
-                  <a:srgbClr val="52606D"/>
+                  <a:srgbClr val="475467"/>
                 </a:solidFill>
                 <a:latin typeface="Noto Sans"/>
                 <a:ea typeface="Noto Sans"/>
@@ -12904,7 +12904,7 @@
             <a:r>
               <a:rPr sz="1250" b="0">
                 <a:solidFill>
-                  <a:srgbClr val="52606D"/>
+                  <a:srgbClr val="475467"/>
                 </a:solidFill>
                 <a:latin typeface="Noto Sans"/>
                 <a:ea typeface="Noto Sans"/>
@@ -12984,7 +12984,7 @@
             <a:r>
               <a:rPr sz="1250" b="0">
                 <a:solidFill>
-                  <a:srgbClr val="52606D"/>
+                  <a:srgbClr val="475467"/>
                 </a:solidFill>
                 <a:latin typeface="Noto Sans"/>
                 <a:ea typeface="Noto Sans"/>
@@ -13064,7 +13064,7 @@
             <a:r>
               <a:rPr sz="1250" b="0">
                 <a:solidFill>
-                  <a:srgbClr val="52606D"/>
+                  <a:srgbClr val="475467"/>
                 </a:solidFill>
                 <a:latin typeface="Noto Sans"/>
                 <a:ea typeface="Noto Sans"/>
@@ -13196,7 +13196,7 @@
           </a:prstGeom>
           <a:ln w="10160">
             <a:solidFill>
-              <a:srgbClr val="D5DBE1"/>
+              <a:srgbClr val="C9D0D7"/>
             </a:solidFill>
           </a:ln>
         </p:spPr>
@@ -13231,7 +13231,7 @@
           </a:prstGeom>
           <a:ln w="7620">
             <a:solidFill>
-              <a:srgbClr val="D5DBE1"/>
+              <a:srgbClr val="C9D0D7"/>
             </a:solidFill>
           </a:ln>
         </p:spPr>
@@ -13280,7 +13280,7 @@
             <a:r>
               <a:rPr sz="850" b="0">
                 <a:solidFill>
-                  <a:srgbClr val="52606D"/>
+                  <a:srgbClr val="475467"/>
                 </a:solidFill>
                 <a:latin typeface="Noto Sans"/>
                 <a:ea typeface="Noto Sans"/>
@@ -13346,7 +13346,7 @@
           </a:prstGeom>
           <a:ln w="11430">
             <a:solidFill>
-              <a:srgbClr val="52606D"/>
+              <a:srgbClr val="475467"/>
             </a:solidFill>
           </a:ln>
         </p:spPr>
@@ -13381,7 +13381,7 @@
           </a:prstGeom>
           <a:ln w="11430">
             <a:solidFill>
-              <a:srgbClr val="52606D"/>
+              <a:srgbClr val="475467"/>
             </a:solidFill>
           </a:ln>
         </p:spPr>
@@ -13430,7 +13430,7 @@
             <a:r>
               <a:rPr sz="900" b="0">
                 <a:solidFill>
-                  <a:srgbClr val="52606D"/>
+                  <a:srgbClr val="475467"/>
                 </a:solidFill>
                 <a:latin typeface="Noto Sans"/>
                 <a:ea typeface="Noto Sans"/>
@@ -13470,7 +13470,7 @@
             <a:r>
               <a:rPr sz="900" b="0">
                 <a:solidFill>
-                  <a:srgbClr val="52606D"/>
+                  <a:srgbClr val="475467"/>
                 </a:solidFill>
                 <a:latin typeface="Noto Sans"/>
                 <a:ea typeface="Noto Sans"/>
@@ -13775,7 +13775,7 @@
             <a:r>
               <a:rPr sz="1250" b="0">
                 <a:solidFill>
-                  <a:srgbClr val="52606D"/>
+                  <a:srgbClr val="475467"/>
                 </a:solidFill>
                 <a:latin typeface="Noto Sans"/>
                 <a:ea typeface="Noto Sans"/>
@@ -13855,7 +13855,7 @@
             <a:r>
               <a:rPr sz="1250" b="0">
                 <a:solidFill>
-                  <a:srgbClr val="52606D"/>
+                  <a:srgbClr val="475467"/>
                 </a:solidFill>
                 <a:latin typeface="Noto Sans"/>
                 <a:ea typeface="Noto Sans"/>
@@ -13935,7 +13935,7 @@
             <a:r>
               <a:rPr sz="1250" b="0">
                 <a:solidFill>
-                  <a:srgbClr val="52606D"/>
+                  <a:srgbClr val="475467"/>
                 </a:solidFill>
                 <a:latin typeface="Noto Sans"/>
                 <a:ea typeface="Noto Sans"/>
@@ -14015,7 +14015,7 @@
             <a:r>
               <a:rPr sz="1250" b="0">
                 <a:solidFill>
-                  <a:srgbClr val="52606D"/>
+                  <a:srgbClr val="475467"/>
                 </a:solidFill>
                 <a:latin typeface="Noto Sans"/>
                 <a:ea typeface="Noto Sans"/>
@@ -14147,7 +14147,7 @@
           </a:prstGeom>
           <a:ln w="10160">
             <a:solidFill>
-              <a:srgbClr val="D5DBE1"/>
+              <a:srgbClr val="C9D0D7"/>
             </a:solidFill>
           </a:ln>
         </p:spPr>
@@ -14182,7 +14182,7 @@
           </a:prstGeom>
           <a:ln w="7620">
             <a:solidFill>
-              <a:srgbClr val="D5DBE1"/>
+              <a:srgbClr val="C9D0D7"/>
             </a:solidFill>
           </a:ln>
         </p:spPr>
@@ -14231,7 +14231,7 @@
             <a:r>
               <a:rPr sz="850" b="0">
                 <a:solidFill>
-                  <a:srgbClr val="52606D"/>
+                  <a:srgbClr val="475467"/>
                 </a:solidFill>
                 <a:latin typeface="Noto Sans"/>
                 <a:ea typeface="Noto Sans"/>
@@ -14426,7 +14426,7 @@
             <a:r>
               <a:rPr sz="1250" b="0">
                 <a:solidFill>
-                  <a:srgbClr val="52606D"/>
+                  <a:srgbClr val="475467"/>
                 </a:solidFill>
                 <a:latin typeface="Noto Sans"/>
                 <a:ea typeface="Noto Sans"/>
@@ -14581,7 +14581,7 @@
             <a:r>
               <a:rPr sz="1250" b="0">
                 <a:solidFill>
-                  <a:srgbClr val="52606D"/>
+                  <a:srgbClr val="475467"/>
                 </a:solidFill>
                 <a:latin typeface="Noto Sans"/>
                 <a:ea typeface="Noto Sans"/>
@@ -14736,7 +14736,7 @@
             <a:r>
               <a:rPr sz="1250" b="0">
                 <a:solidFill>
-                  <a:srgbClr val="52606D"/>
+                  <a:srgbClr val="475467"/>
                 </a:solidFill>
                 <a:latin typeface="Noto Sans"/>
                 <a:ea typeface="Noto Sans"/>
@@ -14891,7 +14891,7 @@
             <a:r>
               <a:rPr sz="1250" b="0">
                 <a:solidFill>
-                  <a:srgbClr val="52606D"/>
+                  <a:srgbClr val="475467"/>
                 </a:solidFill>
                 <a:latin typeface="Noto Sans"/>
                 <a:ea typeface="Noto Sans"/>
@@ -15023,7 +15023,7 @@
           </a:prstGeom>
           <a:ln w="10160">
             <a:solidFill>
-              <a:srgbClr val="D5DBE1"/>
+              <a:srgbClr val="C9D0D7"/>
             </a:solidFill>
           </a:ln>
         </p:spPr>
@@ -15058,7 +15058,7 @@
           </a:prstGeom>
           <a:ln w="7620">
             <a:solidFill>
-              <a:srgbClr val="D5DBE1"/>
+              <a:srgbClr val="C9D0D7"/>
             </a:solidFill>
           </a:ln>
         </p:spPr>
@@ -15107,7 +15107,7 @@
             <a:r>
               <a:rPr sz="850" b="0">
                 <a:solidFill>
-                  <a:srgbClr val="52606D"/>
+                  <a:srgbClr val="475467"/>
                 </a:solidFill>
                 <a:latin typeface="Noto Sans"/>
                 <a:ea typeface="Noto Sans"/>
@@ -15173,7 +15173,7 @@
           </a:prstGeom>
           <a:ln w="11430">
             <a:solidFill>
-              <a:srgbClr val="52606D"/>
+              <a:srgbClr val="475467"/>
             </a:solidFill>
           </a:ln>
         </p:spPr>
@@ -15208,7 +15208,7 @@
           </a:prstGeom>
           <a:ln w="11430">
             <a:solidFill>
-              <a:srgbClr val="52606D"/>
+              <a:srgbClr val="475467"/>
             </a:solidFill>
           </a:ln>
         </p:spPr>
@@ -15257,7 +15257,7 @@
             <a:r>
               <a:rPr sz="900" b="0">
                 <a:solidFill>
-                  <a:srgbClr val="52606D"/>
+                  <a:srgbClr val="475467"/>
                 </a:solidFill>
                 <a:latin typeface="Noto Sans"/>
                 <a:ea typeface="Noto Sans"/>
@@ -15297,7 +15297,7 @@
             <a:r>
               <a:rPr sz="900" b="0">
                 <a:solidFill>
-                  <a:srgbClr val="52606D"/>
+                  <a:srgbClr val="475467"/>
                 </a:solidFill>
                 <a:latin typeface="Noto Sans"/>
                 <a:ea typeface="Noto Sans"/>
@@ -15613,7 +15613,7 @@
             <a:r>
               <a:rPr sz="1250" b="0">
                 <a:solidFill>
-                  <a:srgbClr val="52606D"/>
+                  <a:srgbClr val="475467"/>
                 </a:solidFill>
                 <a:latin typeface="Noto Sans"/>
                 <a:ea typeface="Noto Sans"/>
@@ -15693,7 +15693,7 @@
             <a:r>
               <a:rPr sz="1250" b="0">
                 <a:solidFill>
-                  <a:srgbClr val="52606D"/>
+                  <a:srgbClr val="475467"/>
                 </a:solidFill>
                 <a:latin typeface="Noto Sans"/>
                 <a:ea typeface="Noto Sans"/>
@@ -15908,7 +15908,7 @@
           </a:prstGeom>
           <a:ln w="10160">
             <a:solidFill>
-              <a:srgbClr val="D5DBE1"/>
+              <a:srgbClr val="C9D0D7"/>
             </a:solidFill>
           </a:ln>
         </p:spPr>
@@ -15943,7 +15943,7 @@
           </a:prstGeom>
           <a:ln w="7620">
             <a:solidFill>
-              <a:srgbClr val="D5DBE1"/>
+              <a:srgbClr val="C9D0D7"/>
             </a:solidFill>
           </a:ln>
         </p:spPr>
@@ -15992,7 +15992,7 @@
             <a:r>
               <a:rPr sz="850" b="0">
                 <a:solidFill>
-                  <a:srgbClr val="52606D"/>
+                  <a:srgbClr val="475467"/>
                 </a:solidFill>
                 <a:latin typeface="Noto Sans"/>
                 <a:ea typeface="Noto Sans"/>
@@ -16058,7 +16058,7 @@
           </a:prstGeom>
           <a:ln w="11430">
             <a:solidFill>
-              <a:srgbClr val="52606D"/>
+              <a:srgbClr val="475467"/>
             </a:solidFill>
           </a:ln>
         </p:spPr>
@@ -16093,7 +16093,7 @@
           </a:prstGeom>
           <a:ln w="11430">
             <a:solidFill>
-              <a:srgbClr val="52606D"/>
+              <a:srgbClr val="475467"/>
             </a:solidFill>
           </a:ln>
         </p:spPr>
@@ -16142,7 +16142,7 @@
             <a:r>
               <a:rPr sz="900" b="0">
                 <a:solidFill>
-                  <a:srgbClr val="52606D"/>
+                  <a:srgbClr val="475467"/>
                 </a:solidFill>
                 <a:latin typeface="Noto Sans"/>
                 <a:ea typeface="Noto Sans"/>
@@ -16182,7 +16182,7 @@
             <a:r>
               <a:rPr sz="900" b="0">
                 <a:solidFill>
-                  <a:srgbClr val="52606D"/>
+                  <a:srgbClr val="475467"/>
                 </a:solidFill>
                 <a:latin typeface="Noto Sans"/>
                 <a:ea typeface="Noto Sans"/>
@@ -16294,7 +16294,7 @@
           </a:prstGeom>
           <a:ln w="12700">
             <a:solidFill>
-              <a:srgbClr val="52606D"/>
+              <a:srgbClr val="475467"/>
             </a:solidFill>
           </a:ln>
         </p:spPr>
@@ -16743,7 +16743,7 @@
             <a:r>
               <a:rPr sz="900" b="0">
                 <a:solidFill>
-                  <a:srgbClr val="52606D"/>
+                  <a:srgbClr val="475467"/>
                 </a:solidFill>
                 <a:latin typeface="Noto Sans"/>
                 <a:ea typeface="Noto Sans"/>
@@ -16783,7 +16783,7 @@
             <a:r>
               <a:rPr sz="900" b="1">
                 <a:solidFill>
-                  <a:srgbClr val="52606D"/>
+                  <a:srgbClr val="475467"/>
                 </a:solidFill>
                 <a:latin typeface="Noto Sans"/>
                 <a:ea typeface="Noto Sans"/>
@@ -16863,7 +16863,7 @@
             <a:r>
               <a:rPr sz="900" b="1">
                 <a:solidFill>
-                  <a:srgbClr val="52606D"/>
+                  <a:srgbClr val="475467"/>
                 </a:solidFill>
                 <a:latin typeface="Noto Sans"/>
                 <a:ea typeface="Noto Sans"/>
@@ -17036,7 +17036,7 @@
           </a:prstGeom>
           <a:ln w="10160">
             <a:solidFill>
-              <a:srgbClr val="D5DBE1"/>
+              <a:srgbClr val="C9D0D7"/>
             </a:solidFill>
           </a:ln>
         </p:spPr>
@@ -17071,7 +17071,7 @@
           </a:prstGeom>
           <a:ln w="7620">
             <a:solidFill>
-              <a:srgbClr val="D5DBE1"/>
+              <a:srgbClr val="C9D0D7"/>
             </a:solidFill>
           </a:ln>
         </p:spPr>
@@ -17120,7 +17120,7 @@
             <a:r>
               <a:rPr sz="850" b="0">
                 <a:solidFill>
-                  <a:srgbClr val="52606D"/>
+                  <a:srgbClr val="475467"/>
                 </a:solidFill>
                 <a:latin typeface="Noto Sans"/>
                 <a:ea typeface="Noto Sans"/>
@@ -17189,7 +17189,7 @@
           </a:solidFill>
           <a:ln w="5080">
             <a:solidFill>
-              <a:srgbClr val="D5DBE1"/>
+              <a:srgbClr val="C9D0D7"/>
             </a:solidFill>
           </a:ln>
         </p:spPr>
@@ -17274,7 +17274,7 @@
           </a:solidFill>
           <a:ln w="5080">
             <a:solidFill>
-              <a:srgbClr val="D5DBE1"/>
+              <a:srgbClr val="C9D0D7"/>
             </a:solidFill>
           </a:ln>
         </p:spPr>
@@ -17359,7 +17359,7 @@
           </a:solidFill>
           <a:ln w="5080">
             <a:solidFill>
-              <a:srgbClr val="D5DBE1"/>
+              <a:srgbClr val="C9D0D7"/>
             </a:solidFill>
           </a:ln>
         </p:spPr>
@@ -17444,7 +17444,7 @@
           </a:solidFill>
           <a:ln w="5080">
             <a:solidFill>
-              <a:srgbClr val="D5DBE1"/>
+              <a:srgbClr val="C9D0D7"/>
             </a:solidFill>
           </a:ln>
         </p:spPr>
@@ -17529,7 +17529,7 @@
           </a:solidFill>
           <a:ln w="5080">
             <a:solidFill>
-              <a:srgbClr val="D5DBE1"/>
+              <a:srgbClr val="C9D0D7"/>
             </a:solidFill>
           </a:ln>
         </p:spPr>
@@ -17614,7 +17614,7 @@
           </a:solidFill>
           <a:ln w="5080">
             <a:solidFill>
-              <a:srgbClr val="D5DBE1"/>
+              <a:srgbClr val="C9D0D7"/>
             </a:solidFill>
           </a:ln>
         </p:spPr>
@@ -17699,7 +17699,7 @@
           </a:solidFill>
           <a:ln w="5080">
             <a:solidFill>
-              <a:srgbClr val="D5DBE1"/>
+              <a:srgbClr val="C9D0D7"/>
             </a:solidFill>
           </a:ln>
         </p:spPr>
@@ -17784,7 +17784,7 @@
           </a:solidFill>
           <a:ln w="5080">
             <a:solidFill>
-              <a:srgbClr val="D5DBE1"/>
+              <a:srgbClr val="C9D0D7"/>
             </a:solidFill>
           </a:ln>
         </p:spPr>
@@ -17869,7 +17869,7 @@
           </a:solidFill>
           <a:ln w="5080">
             <a:solidFill>
-              <a:srgbClr val="D5DBE1"/>
+              <a:srgbClr val="C9D0D7"/>
             </a:solidFill>
           </a:ln>
         </p:spPr>
@@ -17954,7 +17954,7 @@
           </a:solidFill>
           <a:ln w="5080">
             <a:solidFill>
-              <a:srgbClr val="D5DBE1"/>
+              <a:srgbClr val="C9D0D7"/>
             </a:solidFill>
           </a:ln>
         </p:spPr>
@@ -18039,7 +18039,7 @@
           </a:solidFill>
           <a:ln w="5080">
             <a:solidFill>
-              <a:srgbClr val="D5DBE1"/>
+              <a:srgbClr val="C9D0D7"/>
             </a:solidFill>
           </a:ln>
         </p:spPr>
@@ -18124,7 +18124,7 @@
           </a:solidFill>
           <a:ln w="5080">
             <a:solidFill>
-              <a:srgbClr val="D5DBE1"/>
+              <a:srgbClr val="C9D0D7"/>
             </a:solidFill>
           </a:ln>
         </p:spPr>
@@ -18209,7 +18209,7 @@
           </a:solidFill>
           <a:ln w="5080">
             <a:solidFill>
-              <a:srgbClr val="D5DBE1"/>
+              <a:srgbClr val="C9D0D7"/>
             </a:solidFill>
           </a:ln>
         </p:spPr>
@@ -18294,7 +18294,7 @@
           </a:solidFill>
           <a:ln w="5080">
             <a:solidFill>
-              <a:srgbClr val="D5DBE1"/>
+              <a:srgbClr val="C9D0D7"/>
             </a:solidFill>
           </a:ln>
         </p:spPr>
@@ -18379,7 +18379,7 @@
           </a:solidFill>
           <a:ln w="5080">
             <a:solidFill>
-              <a:srgbClr val="D5DBE1"/>
+              <a:srgbClr val="C9D0D7"/>
             </a:solidFill>
           </a:ln>
         </p:spPr>
@@ -18464,7 +18464,7 @@
           </a:solidFill>
           <a:ln w="5080">
             <a:solidFill>
-              <a:srgbClr val="D5DBE1"/>
+              <a:srgbClr val="C9D0D7"/>
             </a:solidFill>
           </a:ln>
         </p:spPr>
@@ -18549,7 +18549,7 @@
           </a:solidFill>
           <a:ln w="5080">
             <a:solidFill>
-              <a:srgbClr val="D5DBE1"/>
+              <a:srgbClr val="C9D0D7"/>
             </a:solidFill>
           </a:ln>
         </p:spPr>
@@ -18634,7 +18634,7 @@
           </a:solidFill>
           <a:ln w="5080">
             <a:solidFill>
-              <a:srgbClr val="D5DBE1"/>
+              <a:srgbClr val="C9D0D7"/>
             </a:solidFill>
           </a:ln>
         </p:spPr>
@@ -18719,7 +18719,7 @@
           </a:solidFill>
           <a:ln w="5080">
             <a:solidFill>
-              <a:srgbClr val="D5DBE1"/>
+              <a:srgbClr val="C9D0D7"/>
             </a:solidFill>
           </a:ln>
         </p:spPr>
@@ -18804,7 +18804,7 @@
           </a:solidFill>
           <a:ln w="5080">
             <a:solidFill>
-              <a:srgbClr val="D5DBE1"/>
+              <a:srgbClr val="C9D0D7"/>
             </a:solidFill>
           </a:ln>
         </p:spPr>
@@ -18889,7 +18889,7 @@
           </a:solidFill>
           <a:ln w="5080">
             <a:solidFill>
-              <a:srgbClr val="D5DBE1"/>
+              <a:srgbClr val="C9D0D7"/>
             </a:solidFill>
           </a:ln>
         </p:spPr>
@@ -18974,7 +18974,7 @@
           </a:solidFill>
           <a:ln w="5080">
             <a:solidFill>
-              <a:srgbClr val="D5DBE1"/>
+              <a:srgbClr val="C9D0D7"/>
             </a:solidFill>
           </a:ln>
         </p:spPr>
@@ -19059,7 +19059,7 @@
           </a:solidFill>
           <a:ln w="5080">
             <a:solidFill>
-              <a:srgbClr val="D5DBE1"/>
+              <a:srgbClr val="C9D0D7"/>
             </a:solidFill>
           </a:ln>
         </p:spPr>
@@ -19144,7 +19144,7 @@
           </a:solidFill>
           <a:ln w="5080">
             <a:solidFill>
-              <a:srgbClr val="D5DBE1"/>
+              <a:srgbClr val="C9D0D7"/>
             </a:solidFill>
           </a:ln>
         </p:spPr>
@@ -19229,7 +19229,7 @@
           </a:solidFill>
           <a:ln w="5080">
             <a:solidFill>
-              <a:srgbClr val="D5DBE1"/>
+              <a:srgbClr val="C9D0D7"/>
             </a:solidFill>
           </a:ln>
         </p:spPr>
@@ -19314,7 +19314,7 @@
           </a:solidFill>
           <a:ln w="5080">
             <a:solidFill>
-              <a:srgbClr val="D5DBE1"/>
+              <a:srgbClr val="C9D0D7"/>
             </a:solidFill>
           </a:ln>
         </p:spPr>
@@ -19399,7 +19399,7 @@
           </a:solidFill>
           <a:ln w="5080">
             <a:solidFill>
-              <a:srgbClr val="D5DBE1"/>
+              <a:srgbClr val="C9D0D7"/>
             </a:solidFill>
           </a:ln>
         </p:spPr>
@@ -19484,7 +19484,7 @@
           </a:solidFill>
           <a:ln w="5080">
             <a:solidFill>
-              <a:srgbClr val="D5DBE1"/>
+              <a:srgbClr val="C9D0D7"/>
             </a:solidFill>
           </a:ln>
         </p:spPr>
@@ -19672,7 +19672,7 @@
           </a:prstGeom>
           <a:ln w="10160">
             <a:solidFill>
-              <a:srgbClr val="D5DBE1"/>
+              <a:srgbClr val="C9D0D7"/>
             </a:solidFill>
           </a:ln>
         </p:spPr>
@@ -19707,7 +19707,7 @@
           </a:prstGeom>
           <a:ln w="7620">
             <a:solidFill>
-              <a:srgbClr val="D5DBE1"/>
+              <a:srgbClr val="C9D0D7"/>
             </a:solidFill>
           </a:ln>
         </p:spPr>
@@ -19756,7 +19756,7 @@
             <a:r>
               <a:rPr sz="850" b="0">
                 <a:solidFill>
-                  <a:srgbClr val="52606D"/>
+                  <a:srgbClr val="475467"/>
                 </a:solidFill>
                 <a:latin typeface="Noto Sans"/>
                 <a:ea typeface="Noto Sans"/>
@@ -19916,7 +19916,7 @@
             <a:r>
               <a:rPr sz="1350" b="0">
                 <a:solidFill>
-                  <a:srgbClr val="52606D"/>
+                  <a:srgbClr val="475467"/>
                 </a:solidFill>
                 <a:latin typeface="Noto Sans"/>
                 <a:ea typeface="Noto Sans"/>
@@ -19977,7 +19977,7 @@
           </a:prstGeom>
           <a:ln w="8890">
             <a:solidFill>
-              <a:srgbClr val="D5DBE1"/>
+              <a:srgbClr val="C9D0D7"/>
             </a:solidFill>
           </a:ln>
         </p:spPr>
@@ -20106,7 +20106,7 @@
             <a:r>
               <a:rPr sz="1350" b="0">
                 <a:solidFill>
-                  <a:srgbClr val="52606D"/>
+                  <a:srgbClr val="475467"/>
                 </a:solidFill>
                 <a:latin typeface="Noto Sans"/>
                 <a:ea typeface="Noto Sans"/>
@@ -20167,7 +20167,7 @@
           </a:prstGeom>
           <a:ln w="8890">
             <a:solidFill>
-              <a:srgbClr val="D5DBE1"/>
+              <a:srgbClr val="C9D0D7"/>
             </a:solidFill>
           </a:ln>
         </p:spPr>
@@ -20296,7 +20296,7 @@
             <a:r>
               <a:rPr sz="1350" b="0">
                 <a:solidFill>
-                  <a:srgbClr val="52606D"/>
+                  <a:srgbClr val="475467"/>
                 </a:solidFill>
                 <a:latin typeface="Noto Sans"/>
                 <a:ea typeface="Noto Sans"/>
@@ -20463,7 +20463,7 @@
           </a:prstGeom>
           <a:ln w="10160">
             <a:solidFill>
-              <a:srgbClr val="D5DBE1"/>
+              <a:srgbClr val="C9D0D7"/>
             </a:solidFill>
           </a:ln>
         </p:spPr>
@@ -20498,7 +20498,7 @@
           </a:prstGeom>
           <a:ln w="7620">
             <a:solidFill>
-              <a:srgbClr val="D5DBE1"/>
+              <a:srgbClr val="C9D0D7"/>
             </a:solidFill>
           </a:ln>
         </p:spPr>
@@ -20547,7 +20547,7 @@
             <a:r>
               <a:rPr sz="850" b="0">
                 <a:solidFill>
-                  <a:srgbClr val="52606D"/>
+                  <a:srgbClr val="475467"/>
                 </a:solidFill>
                 <a:latin typeface="Noto Sans"/>
                 <a:ea typeface="Noto Sans"/>
@@ -20696,7 +20696,7 @@
           </a:solidFill>
           <a:ln w="7620">
             <a:solidFill>
-              <a:srgbClr val="D5DBE1"/>
+              <a:srgbClr val="C9D0D7"/>
             </a:solidFill>
           </a:ln>
         </p:spPr>
@@ -20752,7 +20752,7 @@
             <a:r>
               <a:rPr sz="1000" b="1">
                 <a:solidFill>
-                  <a:srgbClr val="52606D"/>
+                  <a:srgbClr val="475467"/>
                 </a:solidFill>
                 <a:latin typeface="Noto Sans"/>
                 <a:ea typeface="Noto Sans"/>
@@ -20781,7 +20781,7 @@
           </a:solidFill>
           <a:ln w="7620">
             <a:solidFill>
-              <a:srgbClr val="D5DBE1"/>
+              <a:srgbClr val="C9D0D7"/>
             </a:solidFill>
           </a:ln>
         </p:spPr>
@@ -20826,7 +20826,7 @@
           </a:solidFill>
           <a:ln w="7620">
             <a:solidFill>
-              <a:srgbClr val="D5DBE1"/>
+              <a:srgbClr val="C9D0D7"/>
             </a:solidFill>
           </a:ln>
         </p:spPr>
@@ -20951,7 +20951,7 @@
           </a:solidFill>
           <a:ln w="7620">
             <a:solidFill>
-              <a:srgbClr val="D5DBE1"/>
+              <a:srgbClr val="C9D0D7"/>
             </a:solidFill>
           </a:ln>
         </p:spPr>
@@ -21007,7 +21007,7 @@
             <a:r>
               <a:rPr sz="1000" b="1">
                 <a:solidFill>
-                  <a:srgbClr val="52606D"/>
+                  <a:srgbClr val="475467"/>
                 </a:solidFill>
                 <a:latin typeface="Noto Sans"/>
                 <a:ea typeface="Noto Sans"/>
@@ -21036,7 +21036,7 @@
           </a:solidFill>
           <a:ln w="7620">
             <a:solidFill>
-              <a:srgbClr val="D5DBE1"/>
+              <a:srgbClr val="C9D0D7"/>
             </a:solidFill>
           </a:ln>
         </p:spPr>
@@ -21081,7 +21081,7 @@
           </a:solidFill>
           <a:ln w="7620">
             <a:solidFill>
-              <a:srgbClr val="D5DBE1"/>
+              <a:srgbClr val="C9D0D7"/>
             </a:solidFill>
           </a:ln>
         </p:spPr>
@@ -21206,7 +21206,7 @@
           </a:solidFill>
           <a:ln w="7620">
             <a:solidFill>
-              <a:srgbClr val="D5DBE1"/>
+              <a:srgbClr val="C9D0D7"/>
             </a:solidFill>
           </a:ln>
         </p:spPr>
@@ -21262,7 +21262,7 @@
             <a:r>
               <a:rPr sz="1000" b="1">
                 <a:solidFill>
-                  <a:srgbClr val="52606D"/>
+                  <a:srgbClr val="475467"/>
                 </a:solidFill>
                 <a:latin typeface="Noto Sans"/>
                 <a:ea typeface="Noto Sans"/>
@@ -21291,7 +21291,7 @@
           </a:solidFill>
           <a:ln w="7620">
             <a:solidFill>
-              <a:srgbClr val="D5DBE1"/>
+              <a:srgbClr val="C9D0D7"/>
             </a:solidFill>
           </a:ln>
         </p:spPr>
@@ -21336,7 +21336,7 @@
           </a:solidFill>
           <a:ln w="7620">
             <a:solidFill>
-              <a:srgbClr val="D5DBE1"/>
+              <a:srgbClr val="C9D0D7"/>
             </a:solidFill>
           </a:ln>
         </p:spPr>
@@ -21461,7 +21461,7 @@
           </a:solidFill>
           <a:ln w="7620">
             <a:solidFill>
-              <a:srgbClr val="D5DBE1"/>
+              <a:srgbClr val="C9D0D7"/>
             </a:solidFill>
           </a:ln>
         </p:spPr>
@@ -21517,7 +21517,7 @@
             <a:r>
               <a:rPr sz="1000" b="1">
                 <a:solidFill>
-                  <a:srgbClr val="52606D"/>
+                  <a:srgbClr val="475467"/>
                 </a:solidFill>
                 <a:latin typeface="Noto Sans"/>
                 <a:ea typeface="Noto Sans"/>
@@ -21546,7 +21546,7 @@
           </a:solidFill>
           <a:ln w="7620">
             <a:solidFill>
-              <a:srgbClr val="D5DBE1"/>
+              <a:srgbClr val="C9D0D7"/>
             </a:solidFill>
           </a:ln>
         </p:spPr>
@@ -21591,7 +21591,7 @@
           </a:solidFill>
           <a:ln w="7620">
             <a:solidFill>
-              <a:srgbClr val="D5DBE1"/>
+              <a:srgbClr val="C9D0D7"/>
             </a:solidFill>
           </a:ln>
         </p:spPr>
@@ -21819,7 +21819,7 @@
           </a:prstGeom>
           <a:ln w="10160">
             <a:solidFill>
-              <a:srgbClr val="D5DBE1"/>
+              <a:srgbClr val="C9D0D7"/>
             </a:solidFill>
           </a:ln>
         </p:spPr>
@@ -21854,7 +21854,7 @@
           </a:prstGeom>
           <a:ln w="7620">
             <a:solidFill>
-              <a:srgbClr val="D5DBE1"/>
+              <a:srgbClr val="C9D0D7"/>
             </a:solidFill>
           </a:ln>
         </p:spPr>
@@ -21903,7 +21903,7 @@
             <a:r>
               <a:rPr sz="850" b="0">
                 <a:solidFill>
-                  <a:srgbClr val="52606D"/>
+                  <a:srgbClr val="475467"/>
                 </a:solidFill>
                 <a:latin typeface="Noto Sans"/>
                 <a:ea typeface="Noto Sans"/>
@@ -21969,7 +21969,7 @@
           </a:prstGeom>
           <a:ln w="17780">
             <a:solidFill>
-              <a:srgbClr val="D5DBE1"/>
+              <a:srgbClr val="C9D0D7"/>
             </a:solidFill>
           </a:ln>
         </p:spPr>
@@ -22141,7 +22141,7 @@
             <a:r>
               <a:rPr sz="1150" b="0">
                 <a:solidFill>
-                  <a:srgbClr val="52606D"/>
+                  <a:srgbClr val="475467"/>
                 </a:solidFill>
                 <a:latin typeface="Noto Sans"/>
                 <a:ea typeface="Noto Sans"/>
@@ -22344,7 +22344,7 @@
             <a:r>
               <a:rPr sz="1150" b="0">
                 <a:solidFill>
-                  <a:srgbClr val="52606D"/>
+                  <a:srgbClr val="475467"/>
                 </a:solidFill>
                 <a:latin typeface="Noto Sans"/>
                 <a:ea typeface="Noto Sans"/>
@@ -22547,7 +22547,7 @@
             <a:r>
               <a:rPr sz="1150" b="0">
                 <a:solidFill>
-                  <a:srgbClr val="52606D"/>
+                  <a:srgbClr val="475467"/>
                 </a:solidFill>
                 <a:latin typeface="Noto Sans"/>
                 <a:ea typeface="Noto Sans"/>
@@ -22750,7 +22750,7 @@
             <a:r>
               <a:rPr sz="1150" b="0">
                 <a:solidFill>
-                  <a:srgbClr val="52606D"/>
+                  <a:srgbClr val="475467"/>
                 </a:solidFill>
                 <a:latin typeface="Noto Sans"/>
                 <a:ea typeface="Noto Sans"/>
@@ -22882,7 +22882,7 @@
           </a:prstGeom>
           <a:ln w="10160">
             <a:solidFill>
-              <a:srgbClr val="D5DBE1"/>
+              <a:srgbClr val="C9D0D7"/>
             </a:solidFill>
           </a:ln>
         </p:spPr>
@@ -22917,7 +22917,7 @@
           </a:prstGeom>
           <a:ln w="7620">
             <a:solidFill>
-              <a:srgbClr val="D5DBE1"/>
+              <a:srgbClr val="C9D0D7"/>
             </a:solidFill>
           </a:ln>
         </p:spPr>
@@ -22966,7 +22966,7 @@
             <a:r>
               <a:rPr sz="850" b="0">
                 <a:solidFill>
-                  <a:srgbClr val="52606D"/>
+                  <a:srgbClr val="475467"/>
                 </a:solidFill>
                 <a:latin typeface="Noto Sans"/>
                 <a:ea typeface="Noto Sans"/>
@@ -23035,7 +23035,7 @@
           </a:solidFill>
           <a:ln w="7620">
             <a:solidFill>
-              <a:srgbClr val="D5DBE1"/>
+              <a:srgbClr val="C9D0D7"/>
             </a:solidFill>
           </a:ln>
         </p:spPr>
@@ -23160,7 +23160,7 @@
           </a:prstGeom>
           <a:ln w="12700">
             <a:solidFill>
-              <a:srgbClr val="52606D"/>
+              <a:srgbClr val="475467"/>
             </a:solidFill>
           </a:ln>
         </p:spPr>
@@ -23194,7 +23194,7 @@
             <a:avLst/>
           </a:prstGeom>
           <a:solidFill>
-            <a:srgbClr val="52606D"/>
+            <a:srgbClr val="475467"/>
           </a:solidFill>
           <a:ln>
             <a:noFill/>
@@ -23252,7 +23252,7 @@
             <a:r>
               <a:rPr sz="850" b="0">
                 <a:solidFill>
-                  <a:srgbClr val="52606D"/>
+                  <a:srgbClr val="475467"/>
                 </a:solidFill>
                 <a:latin typeface="Noto Sans"/>
                 <a:ea typeface="Noto Sans"/>
@@ -23281,7 +23281,7 @@
           </a:solidFill>
           <a:ln w="7620">
             <a:solidFill>
-              <a:srgbClr val="D5DBE1"/>
+              <a:srgbClr val="C9D0D7"/>
             </a:solidFill>
           </a:ln>
         </p:spPr>
@@ -23406,7 +23406,7 @@
           </a:prstGeom>
           <a:ln w="12700">
             <a:solidFill>
-              <a:srgbClr val="52606D"/>
+              <a:srgbClr val="475467"/>
             </a:solidFill>
           </a:ln>
         </p:spPr>
@@ -23440,7 +23440,7 @@
             <a:avLst/>
           </a:prstGeom>
           <a:solidFill>
-            <a:srgbClr val="52606D"/>
+            <a:srgbClr val="475467"/>
           </a:solidFill>
           <a:ln>
             <a:noFill/>
@@ -23498,7 +23498,7 @@
             <a:r>
               <a:rPr sz="850" b="0">
                 <a:solidFill>
-                  <a:srgbClr val="52606D"/>
+                  <a:srgbClr val="475467"/>
                 </a:solidFill>
                 <a:latin typeface="Noto Sans"/>
                 <a:ea typeface="Noto Sans"/>
@@ -23527,7 +23527,7 @@
           </a:solidFill>
           <a:ln w="7620">
             <a:solidFill>
-              <a:srgbClr val="D5DBE1"/>
+              <a:srgbClr val="C9D0D7"/>
             </a:solidFill>
           </a:ln>
         </p:spPr>
@@ -23652,7 +23652,7 @@
           </a:prstGeom>
           <a:ln w="12700">
             <a:solidFill>
-              <a:srgbClr val="52606D"/>
+              <a:srgbClr val="475467"/>
             </a:solidFill>
           </a:ln>
         </p:spPr>
@@ -23686,7 +23686,7 @@
             <a:avLst/>
           </a:prstGeom>
           <a:solidFill>
-            <a:srgbClr val="52606D"/>
+            <a:srgbClr val="475467"/>
           </a:solidFill>
           <a:ln>
             <a:noFill/>
@@ -23744,7 +23744,7 @@
             <a:r>
               <a:rPr sz="850" b="0">
                 <a:solidFill>
-                  <a:srgbClr val="52606D"/>
+                  <a:srgbClr val="475467"/>
                 </a:solidFill>
                 <a:latin typeface="Noto Sans"/>
                 <a:ea typeface="Noto Sans"/>
@@ -23773,7 +23773,7 @@
           </a:solidFill>
           <a:ln w="7620">
             <a:solidFill>
-              <a:srgbClr val="D5DBE1"/>
+              <a:srgbClr val="C9D0D7"/>
             </a:solidFill>
           </a:ln>
         </p:spPr>
@@ -24087,7 +24087,7 @@
           </a:prstGeom>
           <a:ln w="10160">
             <a:solidFill>
-              <a:srgbClr val="D5DBE1"/>
+              <a:srgbClr val="C9D0D7"/>
             </a:solidFill>
           </a:ln>
         </p:spPr>
@@ -24122,7 +24122,7 @@
           </a:prstGeom>
           <a:ln w="7620">
             <a:solidFill>
-              <a:srgbClr val="D5DBE1"/>
+              <a:srgbClr val="C9D0D7"/>
             </a:solidFill>
           </a:ln>
         </p:spPr>
@@ -24171,7 +24171,7 @@
             <a:r>
               <a:rPr sz="850" b="0">
                 <a:solidFill>
-                  <a:srgbClr val="52606D"/>
+                  <a:srgbClr val="475467"/>
                 </a:solidFill>
                 <a:latin typeface="Noto Sans"/>
                 <a:ea typeface="Noto Sans"/>
@@ -24323,7 +24323,7 @@
           </a:solidFill>
           <a:ln w="7620">
             <a:solidFill>
-              <a:srgbClr val="D5DBE1"/>
+              <a:srgbClr val="C9D0D7"/>
             </a:solidFill>
           </a:ln>
         </p:spPr>
@@ -24462,7 +24462,7 @@
             <a:r>
               <a:rPr sz="1050" b="0">
                 <a:solidFill>
-                  <a:srgbClr val="52606D"/>
+                  <a:srgbClr val="475467"/>
                 </a:solidFill>
                 <a:latin typeface="Noto Sans"/>
                 <a:ea typeface="Noto Sans"/>
@@ -24488,7 +24488,7 @@
           </a:prstGeom>
           <a:ln w="12700">
             <a:solidFill>
-              <a:srgbClr val="D5DBE1"/>
+              <a:srgbClr val="C9D0D7"/>
             </a:solidFill>
           </a:ln>
         </p:spPr>
@@ -24526,7 +24526,7 @@
           </a:solidFill>
           <a:ln w="7620">
             <a:solidFill>
-              <a:srgbClr val="D5DBE1"/>
+              <a:srgbClr val="C9D0D7"/>
             </a:solidFill>
           </a:ln>
         </p:spPr>
@@ -24665,7 +24665,7 @@
             <a:r>
               <a:rPr sz="1050" b="0">
                 <a:solidFill>
-                  <a:srgbClr val="52606D"/>
+                  <a:srgbClr val="475467"/>
                 </a:solidFill>
                 <a:latin typeface="Noto Sans"/>
                 <a:ea typeface="Noto Sans"/>
@@ -24691,7 +24691,7 @@
           </a:prstGeom>
           <a:ln w="12700">
             <a:solidFill>
-              <a:srgbClr val="D5DBE1"/>
+              <a:srgbClr val="C9D0D7"/>
             </a:solidFill>
           </a:ln>
         </p:spPr>
@@ -24729,7 +24729,7 @@
           </a:solidFill>
           <a:ln w="7620">
             <a:solidFill>
-              <a:srgbClr val="D5DBE1"/>
+              <a:srgbClr val="C9D0D7"/>
             </a:solidFill>
           </a:ln>
         </p:spPr>
@@ -24868,7 +24868,7 @@
             <a:r>
               <a:rPr sz="1050" b="0">
                 <a:solidFill>
-                  <a:srgbClr val="52606D"/>
+                  <a:srgbClr val="475467"/>
                 </a:solidFill>
                 <a:latin typeface="Noto Sans"/>
                 <a:ea typeface="Noto Sans"/>
@@ -24894,7 +24894,7 @@
           </a:prstGeom>
           <a:ln w="12700">
             <a:solidFill>
-              <a:srgbClr val="D5DBE1"/>
+              <a:srgbClr val="C9D0D7"/>
             </a:solidFill>
           </a:ln>
         </p:spPr>
@@ -24932,7 +24932,7 @@
           </a:solidFill>
           <a:ln w="7620">
             <a:solidFill>
-              <a:srgbClr val="D5DBE1"/>
+              <a:srgbClr val="C9D0D7"/>
             </a:solidFill>
           </a:ln>
         </p:spPr>
@@ -25071,7 +25071,7 @@
             <a:r>
               <a:rPr sz="1050" b="0">
                 <a:solidFill>
-                  <a:srgbClr val="52606D"/>
+                  <a:srgbClr val="475467"/>
                 </a:solidFill>
                 <a:latin typeface="Noto Sans"/>
                 <a:ea typeface="Noto Sans"/>
@@ -25097,7 +25097,7 @@
           </a:prstGeom>
           <a:ln w="12700">
             <a:solidFill>
-              <a:srgbClr val="D5DBE1"/>
+              <a:srgbClr val="C9D0D7"/>
             </a:solidFill>
           </a:ln>
         </p:spPr>
@@ -25238,7 +25238,7 @@
           </a:prstGeom>
           <a:ln w="10160">
             <a:solidFill>
-              <a:srgbClr val="D5DBE1"/>
+              <a:srgbClr val="C9D0D7"/>
             </a:solidFill>
           </a:ln>
         </p:spPr>
@@ -25273,7 +25273,7 @@
           </a:prstGeom>
           <a:ln w="7620">
             <a:solidFill>
-              <a:srgbClr val="D5DBE1"/>
+              <a:srgbClr val="C9D0D7"/>
             </a:solidFill>
           </a:ln>
         </p:spPr>
@@ -25322,7 +25322,7 @@
             <a:r>
               <a:rPr sz="850" b="0">
                 <a:solidFill>
-                  <a:srgbClr val="52606D"/>
+                  <a:srgbClr val="475467"/>
                 </a:solidFill>
                 <a:latin typeface="Noto Sans"/>
                 <a:ea typeface="Noto Sans"/>
@@ -25477,7 +25477,7 @@
             <a:r>
               <a:rPr sz="1050" b="0">
                 <a:solidFill>
-                  <a:srgbClr val="52606D"/>
+                  <a:srgbClr val="475467"/>
                 </a:solidFill>
                 <a:latin typeface="Noto Sans"/>
                 <a:ea typeface="Noto Sans"/>
@@ -25503,7 +25503,7 @@
           </a:prstGeom>
           <a:ln w="7620">
             <a:solidFill>
-              <a:srgbClr val="D5DBE1"/>
+              <a:srgbClr val="C9D0D7"/>
             </a:solidFill>
           </a:ln>
         </p:spPr>
@@ -25627,7 +25627,7 @@
             <a:r>
               <a:rPr sz="1050" b="0">
                 <a:solidFill>
-                  <a:srgbClr val="52606D"/>
+                  <a:srgbClr val="475467"/>
                 </a:solidFill>
                 <a:latin typeface="Noto Sans"/>
                 <a:ea typeface="Noto Sans"/>
@@ -25653,7 +25653,7 @@
           </a:prstGeom>
           <a:ln w="7620">
             <a:solidFill>
-              <a:srgbClr val="D5DBE1"/>
+              <a:srgbClr val="C9D0D7"/>
             </a:solidFill>
           </a:ln>
         </p:spPr>
@@ -25777,7 +25777,7 @@
             <a:r>
               <a:rPr sz="1050" b="0">
                 <a:solidFill>
-                  <a:srgbClr val="52606D"/>
+                  <a:srgbClr val="475467"/>
                 </a:solidFill>
                 <a:latin typeface="Noto Sans"/>
                 <a:ea typeface="Noto Sans"/>
@@ -25803,7 +25803,7 @@
           </a:prstGeom>
           <a:ln w="7620">
             <a:solidFill>
-              <a:srgbClr val="D5DBE1"/>
+              <a:srgbClr val="C9D0D7"/>
             </a:solidFill>
           </a:ln>
         </p:spPr>
@@ -25927,7 +25927,7 @@
             <a:r>
               <a:rPr sz="1050" b="0">
                 <a:solidFill>
-                  <a:srgbClr val="52606D"/>
+                  <a:srgbClr val="475467"/>
                 </a:solidFill>
                 <a:latin typeface="Noto Sans"/>
                 <a:ea typeface="Noto Sans"/>
@@ -25953,7 +25953,7 @@
           </a:prstGeom>
           <a:ln w="7620">
             <a:solidFill>
-              <a:srgbClr val="D5DBE1"/>
+              <a:srgbClr val="C9D0D7"/>
             </a:solidFill>
           </a:ln>
         </p:spPr>

</xml_diff>